<commit_message>
CSC336 Lecture 11 slides: more type coercion/conversion examples
Slide 14 (Type Coercion) grows from 5 to 7 examples, adding null/
undefined coercion. Two new slides follow it: "Type Coercion — Tricky
Gotchas" (array/object coercion, left-to-right evaluation order, the
"" == 0 and null == undefined special cases) and "Explicit Type
Conversion" (Number()/String()/Boolean()/parseInt(), contrasted with
implicit coercion) — the deck didn't cover explicit conversion at all
before. All footer page numbers from the old slide 15 onward shift by
+2 to stay accurate (39 slides -> 41).

Co-Authored-By: Claude Sonnet 5 <noreply@anthropic.com>
</commit_message>
<xml_diff>
--- a/slides/CSC336-Lecture-11-Core-JavaScript-ES6.pptx
+++ b/slides/CSC336-Lecture-11-Core-JavaScript-ES6.pptx
@@ -19,6 +19,8 @@
     <p:sldId id="267" r:id="rId13"/>
     <p:sldId id="268" r:id="rId14"/>
     <p:sldId id="269" r:id="rId15"/>
+    <p:sldId id="295" r:id="rId46"/>
+    <p:sldId id="296" r:id="rId47"/>
     <p:sldId id="270" r:id="rId16"/>
     <p:sldId id="271" r:id="rId17"/>
     <p:sldId id="272" r:id="rId18"/>
@@ -6567,7 +6569,7 @@
         <p:spPr>
           <a:xfrm>
             <a:off x="640080" y="1965960"/>
-            <a:ext cx="10911535" cy="1882140"/>
+            <a:ext cx="10911535" cy="2452116"/>
           </a:xfrm>
           <a:prstGeom prst="roundRect">
             <a:avLst>
@@ -6593,7 +6595,7 @@
         <p:spPr>
           <a:xfrm>
             <a:off x="960120" y="2194560"/>
-            <a:ext cx="10271455" cy="1424940"/>
+            <a:ext cx="10271455" cy="1994916"/>
           </a:xfrm>
           <a:prstGeom prst="rect">
             <a:avLst/>
@@ -6620,7 +6622,7 @@
                 <a:ea typeface="Courier New" pitchFamily="34" charset="-122"/>
                 <a:cs typeface="Courier New" pitchFamily="34" charset="-120"/>
               </a:rPr>
-              <a:t>console.log("5" + 3);    // "53"  -- number coerced to string, then joined</a:t>
+              <a:t>console.log("5" + 3);        // "53"  -- number coerced to string, then joined</a:t>
             </a:r>
             <a:endParaRPr lang="en-US" sz="1400" dirty="0"/>
           </a:p>
@@ -6640,7 +6642,7 @@
                 <a:ea typeface="Courier New" pitchFamily="34" charset="-122"/>
                 <a:cs typeface="Courier New" pitchFamily="34" charset="-120"/>
               </a:rPr>
-              <a:t>console.log("5" - 3);    // 2     -- string coerced to number</a:t>
+              <a:t>console.log("5" - 3);        // 2     -- string coerced to number</a:t>
             </a:r>
             <a:endParaRPr lang="en-US" sz="1400" dirty="0"/>
           </a:p>
@@ -6660,7 +6662,7 @@
                 <a:ea typeface="Courier New" pitchFamily="34" charset="-122"/>
                 <a:cs typeface="Courier New" pitchFamily="34" charset="-120"/>
               </a:rPr>
-              <a:t>console.log(1 + true);   // 2     -- true coerced to 1</a:t>
+              <a:t>console.log(1 + true);       // 2     -- true coerced to 1</a:t>
             </a:r>
             <a:endParaRPr lang="en-US" sz="1400" dirty="0"/>
           </a:p>
@@ -6680,7 +6682,7 @@
                 <a:ea typeface="Courier New" pitchFamily="34" charset="-122"/>
                 <a:cs typeface="Courier New" pitchFamily="34" charset="-120"/>
               </a:rPr>
-              <a:t>console.log("10" == 10);  // true  -- coercion happens before comparing</a:t>
+              <a:t>console.log(null + 1);       // 1     -- null coerces to 0</a:t>
             </a:r>
             <a:endParaRPr lang="en-US" sz="1400" dirty="0"/>
           </a:p>
@@ -6700,10 +6702,50 @@
                 <a:ea typeface="Courier New" pitchFamily="34" charset="-122"/>
                 <a:cs typeface="Courier New" pitchFamily="34" charset="-120"/>
               </a:rPr>
-              <a:t>console.log("10" === 10); // false -- no coercion, types differ</a:t>
+              <a:t>console.log(undefined + 1);  // NaN   -- undefined coerces to NaN</a:t>
             </a:r>
             <a:endParaRPr lang="en-US" sz="1400" dirty="0"/>
           </a:p>
+          <a:p>
+            <a:pPr indent="0" marL="0">
+              <a:lnSpc>
+                <a:spcPct val="125000"/>
+              </a:lnSpc>
+              <a:buNone/>
+            </a:pPr>
+            <a:r>
+              <a:rPr lang="en-US" sz="1400" dirty="0">
+                <a:solidFill>
+                  <a:srgbClr val="C9D3F5"/>
+                </a:solidFill>
+                <a:latin typeface="Courier New" pitchFamily="34" charset="0"/>
+                <a:ea typeface="Courier New" pitchFamily="34" charset="-122"/>
+                <a:cs typeface="Courier New" pitchFamily="34" charset="-120"/>
+              </a:rPr>
+              <a:t>console.log("10" == 10);     // true  -- coercion happens before comparing</a:t>
+            </a:r>
+            <a:endParaRPr lang="en-US" sz="1400" dirty="0"/>
+          </a:p>
+          <a:p>
+            <a:pPr indent="0" marL="0">
+              <a:lnSpc>
+                <a:spcPct val="125000"/>
+              </a:lnSpc>
+              <a:buNone/>
+            </a:pPr>
+            <a:r>
+              <a:rPr lang="en-US" sz="1400" dirty="0">
+                <a:solidFill>
+                  <a:srgbClr val="C9D3F5"/>
+                </a:solidFill>
+                <a:latin typeface="Courier New" pitchFamily="34" charset="0"/>
+                <a:ea typeface="Courier New" pitchFamily="34" charset="-122"/>
+                <a:cs typeface="Courier New" pitchFamily="34" charset="-120"/>
+              </a:rPr>
+              <a:t>console.log("10" === 10);    // false -- no coercion, types differ</a:t>
+            </a:r>
+            <a:endParaRPr lang="en-US" sz="1400" dirty="0"/>
+          </a:p>
         </p:txBody>
       </p:sp>
       <p:sp>
@@ -6714,8 +6756,8 @@
         </p:nvSpPr>
         <p:spPr>
           <a:xfrm>
-            <a:off x="640080" y="4076700"/>
-            <a:ext cx="10911535" cy="2186940"/>
+            <a:off x="640080" y="4646676"/>
+            <a:ext cx="10911535" cy="1658988"/>
           </a:xfrm>
           <a:prstGeom prst="rect">
             <a:avLst/>
@@ -6739,7 +6781,7 @@
                 <a:ea typeface="Calibri" pitchFamily="34" charset="-122"/>
                 <a:cs typeface="Calibri" pitchFamily="34" charset="-120"/>
               </a:rPr>
-              <a:t>== ("loose equality") converts both sides to a common type first. === ("strict equality") compares value and type, with no conversion.</a:t>
+              <a:t>== (“loose equality”) converts both sides to a common type first. === (“strict equality”) compares value and type, with no conversion. null and undefined behave differently under coercion — that difference trips up beginners constantly.</a:t>
             </a:r>
             <a:endParaRPr lang="en-US" sz="1300" dirty="0"/>
           </a:p>
@@ -7045,7 +7087,7 @@
                   <a:srgbClr val="8A939B"/>
                 </a:solidFill>
               </a:rPr>
-              <a:t>  ·  15</a:t>
+              <a:t>  ·  17</a:t>
             </a:r>
           </a:p>
         </p:txBody>
@@ -7475,7 +7517,7 @@
                   <a:srgbClr val="8A939B"/>
                 </a:solidFill>
               </a:rPr>
-              <a:t>  ·  16</a:t>
+              <a:t>  ·  18</a:t>
             </a:r>
           </a:p>
         </p:txBody>
@@ -7895,7 +7937,7 @@
                   <a:srgbClr val="8A939B"/>
                 </a:solidFill>
               </a:rPr>
-              <a:t>  ·  17</a:t>
+              <a:t>  ·  19</a:t>
             </a:r>
           </a:p>
         </p:txBody>
@@ -8354,7 +8396,7 @@
                   <a:srgbClr val="8A939B"/>
                 </a:solidFill>
               </a:rPr>
-              <a:t>  ·  18</a:t>
+              <a:t>  ·  20</a:t>
             </a:r>
           </a:p>
         </p:txBody>
@@ -8715,7 +8757,7 @@
                   <a:srgbClr val="8A939B"/>
                 </a:solidFill>
               </a:rPr>
-              <a:t>  ·  19</a:t>
+              <a:t>  ·  21</a:t>
             </a:r>
           </a:p>
         </p:txBody>
@@ -10013,7 +10055,7 @@
                   <a:srgbClr val="8A939B"/>
                 </a:solidFill>
               </a:rPr>
-              <a:t>  ·  20</a:t>
+              <a:t>  ·  22</a:t>
             </a:r>
           </a:p>
         </p:txBody>
@@ -10275,7 +10317,7 @@
                   <a:srgbClr val="8A939B"/>
                 </a:solidFill>
               </a:rPr>
-              <a:t>  ·  21</a:t>
+              <a:t>  ·  23</a:t>
             </a:r>
           </a:p>
         </p:txBody>
@@ -10714,7 +10756,7 @@
                   <a:srgbClr val="8A939B"/>
                 </a:solidFill>
               </a:rPr>
-              <a:t>  ·  22</a:t>
+              <a:t>  ·  24</a:t>
             </a:r>
           </a:p>
         </p:txBody>
@@ -10976,7 +11018,7 @@
                   <a:srgbClr val="8A939B"/>
                 </a:solidFill>
               </a:rPr>
-              <a:t>  ·  23</a:t>
+              <a:t>  ·  25</a:t>
             </a:r>
           </a:p>
         </p:txBody>
@@ -11366,7 +11408,7 @@
                   <a:srgbClr val="8A939B"/>
                 </a:solidFill>
               </a:rPr>
-              <a:t>  ·  24</a:t>
+              <a:t>  ·  26</a:t>
             </a:r>
           </a:p>
         </p:txBody>
@@ -11725,7 +11767,7 @@
                   <a:srgbClr val="8A939B"/>
                 </a:solidFill>
               </a:rPr>
-              <a:t>  ·  25</a:t>
+              <a:t>  ·  27</a:t>
             </a:r>
           </a:p>
         </p:txBody>
@@ -11987,7 +12029,7 @@
                   <a:srgbClr val="8A939B"/>
                 </a:solidFill>
               </a:rPr>
-              <a:t>  ·  26</a:t>
+              <a:t>  ·  28</a:t>
             </a:r>
           </a:p>
         </p:txBody>
@@ -12366,7 +12408,7 @@
                   <a:srgbClr val="8A939B"/>
                 </a:solidFill>
               </a:rPr>
-              <a:t>  ·  27</a:t>
+              <a:t>  ·  29</a:t>
             </a:r>
           </a:p>
         </p:txBody>
@@ -12756,7 +12798,7 @@
                   <a:srgbClr val="8A939B"/>
                 </a:solidFill>
               </a:rPr>
-              <a:t>  ·  28</a:t>
+              <a:t>  ·  30</a:t>
             </a:r>
           </a:p>
         </p:txBody>
@@ -13165,7 +13207,7 @@
                   <a:srgbClr val="8A939B"/>
                 </a:solidFill>
               </a:rPr>
-              <a:t>  ·  29</a:t>
+              <a:t>  ·  31</a:t>
             </a:r>
           </a:p>
         </p:txBody>
@@ -14474,7 +14516,7 @@
                   <a:srgbClr val="8A939B"/>
                 </a:solidFill>
               </a:rPr>
-              <a:t>  ·  30</a:t>
+              <a:t>  ·  32</a:t>
             </a:r>
           </a:p>
         </p:txBody>
@@ -14894,7 +14936,7 @@
                   <a:srgbClr val="8A939B"/>
                 </a:solidFill>
               </a:rPr>
-              <a:t>  ·  31</a:t>
+              <a:t>  ·  33</a:t>
             </a:r>
           </a:p>
         </p:txBody>
@@ -15392,7 +15434,7 @@
                   <a:srgbClr val="8A939B"/>
                 </a:solidFill>
               </a:rPr>
-              <a:t>  ·  32</a:t>
+              <a:t>  ·  34</a:t>
             </a:r>
           </a:p>
         </p:txBody>
@@ -15851,7 +15893,7 @@
                   <a:srgbClr val="8A939B"/>
                 </a:solidFill>
               </a:rPr>
-              <a:t>  ·  33</a:t>
+              <a:t>  ·  35</a:t>
             </a:r>
           </a:p>
         </p:txBody>
@@ -16280,7 +16322,7 @@
                   <a:srgbClr val="8A939B"/>
                 </a:solidFill>
               </a:rPr>
-              <a:t>  ·  34</a:t>
+              <a:t>  ·  36</a:t>
             </a:r>
           </a:p>
         </p:txBody>
@@ -16710,7 +16752,7 @@
                   <a:srgbClr val="8A939B"/>
                 </a:solidFill>
               </a:rPr>
-              <a:t>  ·  35</a:t>
+              <a:t>  ·  37</a:t>
             </a:r>
           </a:p>
         </p:txBody>
@@ -17137,7 +17179,7 @@
                   <a:srgbClr val="8A939B"/>
                 </a:solidFill>
               </a:rPr>
-              <a:t>  ·  36</a:t>
+              <a:t>  ·  38</a:t>
             </a:r>
           </a:p>
         </p:txBody>
@@ -17546,7 +17588,7 @@
                   <a:srgbClr val="8A939B"/>
                 </a:solidFill>
               </a:rPr>
-              <a:t>  ·  37</a:t>
+              <a:t>  ·  39</a:t>
             </a:r>
           </a:p>
         </p:txBody>
@@ -17808,7 +17850,7 @@
                   <a:srgbClr val="8A939B"/>
                 </a:solidFill>
               </a:rPr>
-              <a:t>  ·  38</a:t>
+              <a:t>  ·  40</a:t>
             </a:r>
           </a:p>
         </p:txBody>
@@ -18675,7 +18717,7 @@
                   <a:srgbClr val="8A939B"/>
                 </a:solidFill>
               </a:rPr>
-              <a:t>  ·  39</a:t>
+              <a:t>  ·  41</a:t>
             </a:r>
           </a:p>
         </p:txBody>
@@ -19094,6 +19136,766 @@
                 </a:solidFill>
               </a:rPr>
               <a:t>  ·  4</a:t>
+            </a:r>
+          </a:p>
+        </p:txBody>
+      </p:sp>
+    </p:spTree>
+  </p:cSld>
+  <p:clrMapOvr>
+    <a:masterClrMapping/>
+  </p:clrMapOvr>
+</p:sld>
+</file>
+
+<file path=ppt/slides/slide40.xml><?xml version="1.0" encoding="utf-8"?>
+<p:sld xmlns:a="http://schemas.openxmlformats.org/drawingml/2006/main" xmlns:r="http://schemas.openxmlformats.org/officeDocument/2006/relationships" xmlns:p="http://schemas.openxmlformats.org/presentationml/2006/main">
+  <p:cSld name="Slide 15">
+    <p:bg>
+      <p:bgPr>
+        <a:solidFill>
+          <a:srgbClr val="FFFFFF"/>
+        </a:solidFill>
+      </p:bgPr>
+    </p:bg>
+    <p:spTree>
+      <p:nvGrpSpPr>
+        <p:cNvPr id="1" name=""/>
+        <p:cNvGrpSpPr/>
+        <p:nvPr/>
+      </p:nvGrpSpPr>
+      <p:grpSpPr>
+        <a:xfrm>
+          <a:off x="0" y="0"/>
+          <a:ext cx="0" cy="0"/>
+          <a:chOff x="0" y="0"/>
+          <a:chExt cx="0" cy="0"/>
+        </a:xfrm>
+      </p:grpSpPr>
+      <p:sp>
+        <p:nvSpPr>
+          <p:cNvPr id="2" name="Text 0"/>
+          <p:cNvSpPr txBox="1"/>
+          <p:nvPr/>
+        </p:nvSpPr>
+        <p:spPr>
+          <a:xfrm>
+            <a:off x="640080" y="457200"/>
+            <a:ext cx="10058400" cy="365760"/>
+          </a:xfrm>
+          <a:prstGeom prst="rect">
+            <a:avLst/>
+          </a:prstGeom>
+          <a:noFill/>
+          <a:ln/>
+        </p:spPr>
+        <p:txBody>
+          <a:bodyPr wrap="square" lIns="0" tIns="0" rIns="0" bIns="0" rtlCol="0" anchor="ctr"/>
+          <a:lstStyle/>
+          <a:p>
+            <a:pPr algn="l" indent="0" marL="0">
+              <a:buNone/>
+            </a:pPr>
+            <a:r>
+              <a:rPr lang="en-US" sz="1300" b="1" spc="300" kern="0" dirty="0">
+                <a:solidFill>
+                  <a:srgbClr val="FF8A3D"/>
+                </a:solidFill>
+                <a:latin typeface="Calibri" pitchFamily="34" charset="0"/>
+                <a:ea typeface="Calibri" pitchFamily="34" charset="-122"/>
+                <a:cs typeface="Calibri" pitchFamily="34" charset="-120"/>
+              </a:rPr>
+              <a:t>OPERATORS</a:t>
+            </a:r>
+            <a:endParaRPr lang="en-US" sz="1300" dirty="0"/>
+          </a:p>
+        </p:txBody>
+      </p:sp>
+      <p:sp>
+        <p:nvSpPr>
+          <p:cNvPr id="3" name="Text 1"/>
+          <p:cNvSpPr txBox="1"/>
+          <p:nvPr/>
+        </p:nvSpPr>
+        <p:spPr>
+          <a:xfrm>
+            <a:off x="640080" y="841248"/>
+            <a:ext cx="10881360" cy="914400"/>
+          </a:xfrm>
+          <a:prstGeom prst="rect">
+            <a:avLst/>
+          </a:prstGeom>
+          <a:noFill/>
+          <a:ln/>
+        </p:spPr>
+        <p:txBody>
+          <a:bodyPr wrap="square" lIns="0" tIns="0" rIns="0" bIns="0" rtlCol="0" anchor="ctr"/>
+          <a:lstStyle/>
+          <a:p>
+            <a:pPr algn="l" indent="0" marL="0">
+              <a:buNone/>
+            </a:pPr>
+            <a:r>
+              <a:rPr lang="en-US" sz="3400" b="1" dirty="0">
+                <a:solidFill>
+                  <a:srgbClr val="2B2B7A"/>
+                </a:solidFill>
+                <a:latin typeface="Cambria" pitchFamily="34" charset="0"/>
+                <a:ea typeface="Cambria" pitchFamily="34" charset="-122"/>
+                <a:cs typeface="Cambria" pitchFamily="34" charset="-120"/>
+              </a:rPr>
+              <a:t>Type Coercion — Tricky Gotchas</a:t>
+            </a:r>
+            <a:endParaRPr lang="en-US" sz="3400" dirty="0"/>
+          </a:p>
+        </p:txBody>
+      </p:sp>
+      <p:sp>
+        <p:nvSpPr>
+          <p:cNvPr id="4" name="Shape 2"/>
+          <p:cNvSpPr/>
+          <p:nvPr/>
+        </p:nvSpPr>
+        <p:spPr>
+          <a:xfrm>
+            <a:off x="640080" y="1965960"/>
+            <a:ext cx="10911535" cy="2452116"/>
+          </a:xfrm>
+          <a:prstGeom prst="roundRect">
+            <a:avLst>
+              <a:gd name="adj" fmla="val 3887"/>
+            </a:avLst>
+          </a:prstGeom>
+          <a:solidFill>
+            <a:srgbClr val="1E1E4C"/>
+          </a:solidFill>
+          <a:ln/>
+        </p:spPr>
+        <p:txBody>
+          <a:bodyPr/>
+          <a:p/>
+        </p:txBody>
+      </p:sp>
+      <p:sp>
+        <p:nvSpPr>
+          <p:cNvPr id="5" name="Text 3"/>
+          <p:cNvSpPr txBox="1"/>
+          <p:nvPr/>
+        </p:nvSpPr>
+        <p:spPr>
+          <a:xfrm>
+            <a:off x="960120" y="2194560"/>
+            <a:ext cx="10271455" cy="1994916"/>
+          </a:xfrm>
+          <a:prstGeom prst="rect">
+            <a:avLst/>
+          </a:prstGeom>
+          <a:noFill/>
+          <a:ln/>
+        </p:spPr>
+        <p:txBody>
+          <a:bodyPr wrap="square" lIns="0" tIns="0" rIns="0" bIns="0" rtlCol="0" anchor="t"/>
+          <a:lstStyle/>
+          <a:p>
+            <a:pPr indent="0" marL="0">
+              <a:lnSpc>
+                <a:spcPct val="125000"/>
+              </a:lnSpc>
+              <a:buNone/>
+            </a:pPr>
+            <a:r>
+              <a:rPr lang="en-US" sz="1400" dirty="0">
+                <a:solidFill>
+                  <a:srgbClr val="C9D3F5"/>
+                </a:solidFill>
+                <a:latin typeface="Courier New" pitchFamily="34" charset="0"/>
+                <a:ea typeface="Courier New" pitchFamily="34" charset="-122"/>
+                <a:cs typeface="Courier New" pitchFamily="34" charset="-120"/>
+              </a:rPr>
+              <a:t>console.log([] + []);           // ""       -- both arrays coerce to "", then join</a:t>
+            </a:r>
+            <a:endParaRPr lang="en-US" sz="1400" dirty="0"/>
+          </a:p>
+          <a:p>
+            <a:pPr indent="0" marL="0">
+              <a:lnSpc>
+                <a:spcPct val="125000"/>
+              </a:lnSpc>
+              <a:buNone/>
+            </a:pPr>
+            <a:r>
+              <a:rPr lang="en-US" sz="1400" dirty="0">
+                <a:solidFill>
+                  <a:srgbClr val="C9D3F5"/>
+                </a:solidFill>
+                <a:latin typeface="Courier New" pitchFamily="34" charset="0"/>
+                <a:ea typeface="Courier New" pitchFamily="34" charset="-122"/>
+                <a:cs typeface="Courier New" pitchFamily="34" charset="-120"/>
+              </a:rPr>
+              <a:t>console.log([] + {});           // "[object Object]"</a:t>
+            </a:r>
+            <a:endParaRPr lang="en-US" sz="1400" dirty="0"/>
+          </a:p>
+          <a:p>
+            <a:pPr indent="0" marL="0">
+              <a:lnSpc>
+                <a:spcPct val="125000"/>
+              </a:lnSpc>
+              <a:buNone/>
+            </a:pPr>
+            <a:r>
+              <a:rPr lang="en-US" sz="1400" dirty="0">
+                <a:solidFill>
+                  <a:srgbClr val="C9D3F5"/>
+                </a:solidFill>
+                <a:latin typeface="Courier New" pitchFamily="34" charset="0"/>
+                <a:ea typeface="Courier New" pitchFamily="34" charset="-122"/>
+                <a:cs typeface="Courier New" pitchFamily="34" charset="-120"/>
+              </a:rPr>
+              <a:t>console.log([1,2] + [3,4]);     // "1,23,4"  -- arrays coerce via toString(), then join</a:t>
+            </a:r>
+            <a:endParaRPr lang="en-US" sz="1400" dirty="0"/>
+          </a:p>
+          <a:p>
+            <a:pPr indent="0" marL="0">
+              <a:lnSpc>
+                <a:spcPct val="125000"/>
+              </a:lnSpc>
+              <a:buNone/>
+            </a:pPr>
+            <a:r>
+              <a:rPr lang="en-US" sz="1400" dirty="0">
+                <a:solidFill>
+                  <a:srgbClr val="C9D3F5"/>
+                </a:solidFill>
+                <a:latin typeface="Courier New" pitchFamily="34" charset="0"/>
+                <a:ea typeface="Courier New" pitchFamily="34" charset="-122"/>
+                <a:cs typeface="Courier New" pitchFamily="34" charset="-120"/>
+              </a:rPr>
+              <a:t>console.log(1 + "2" + 3);       // "123"     -- left to right: 1+"2"="12", then +3="123"</a:t>
+            </a:r>
+            <a:endParaRPr lang="en-US" sz="1400" dirty="0"/>
+          </a:p>
+          <a:p>
+            <a:pPr indent="0" marL="0">
+              <a:lnSpc>
+                <a:spcPct val="125000"/>
+              </a:lnSpc>
+              <a:buNone/>
+            </a:pPr>
+            <a:r>
+              <a:rPr lang="en-US" sz="1400" dirty="0">
+                <a:solidFill>
+                  <a:srgbClr val="C9D3F5"/>
+                </a:solidFill>
+                <a:latin typeface="Courier New" pitchFamily="34" charset="0"/>
+                <a:ea typeface="Courier New" pitchFamily="34" charset="-122"/>
+                <a:cs typeface="Courier New" pitchFamily="34" charset="-120"/>
+              </a:rPr>
+              <a:t>console.log(1 + 2 + "3");       // "33"      -- left to right: 1+2=3, then 3+"3"="33"</a:t>
+            </a:r>
+            <a:endParaRPr lang="en-US" sz="1400" dirty="0"/>
+          </a:p>
+          <a:p>
+            <a:pPr indent="0" marL="0">
+              <a:lnSpc>
+                <a:spcPct val="125000"/>
+              </a:lnSpc>
+              <a:buNone/>
+            </a:pPr>
+            <a:r>
+              <a:rPr lang="en-US" sz="1400" dirty="0">
+                <a:solidFill>
+                  <a:srgbClr val="C9D3F5"/>
+                </a:solidFill>
+                <a:latin typeface="Courier New" pitchFamily="34" charset="0"/>
+                <a:ea typeface="Courier New" pitchFamily="34" charset="-122"/>
+                <a:cs typeface="Courier New" pitchFamily="34" charset="-120"/>
+              </a:rPr>
+              <a:t>console.log("" == 0);           // true      -- "" coerces to 0</a:t>
+            </a:r>
+            <a:endParaRPr lang="en-US" sz="1400" dirty="0"/>
+          </a:p>
+          <a:p>
+            <a:pPr indent="0" marL="0">
+              <a:lnSpc>
+                <a:spcPct val="125000"/>
+              </a:lnSpc>
+              <a:buNone/>
+            </a:pPr>
+            <a:r>
+              <a:rPr lang="en-US" sz="1400" dirty="0">
+                <a:solidFill>
+                  <a:srgbClr val="C9D3F5"/>
+                </a:solidFill>
+                <a:latin typeface="Courier New" pitchFamily="34" charset="0"/>
+                <a:ea typeface="Courier New" pitchFamily="34" charset="-122"/>
+                <a:cs typeface="Courier New" pitchFamily="34" charset="-120"/>
+              </a:rPr>
+              <a:t>console.log(null == undefined); // true      -- special case; null === undefined is false</a:t>
+            </a:r>
+            <a:endParaRPr lang="en-US" sz="1400" dirty="0"/>
+          </a:p>
+        </p:txBody>
+      </p:sp>
+      <p:sp>
+        <p:nvSpPr>
+          <p:cNvPr id="6" name="Text 4"/>
+          <p:cNvSpPr txBox="1"/>
+          <p:nvPr/>
+        </p:nvSpPr>
+        <p:spPr>
+          <a:xfrm>
+            <a:off x="640080" y="4646676"/>
+            <a:ext cx="10911535" cy="1658988"/>
+          </a:xfrm>
+          <a:prstGeom prst="rect">
+            <a:avLst/>
+          </a:prstGeom>
+          <a:noFill/>
+          <a:ln/>
+        </p:spPr>
+        <p:txBody>
+          <a:bodyPr wrap="square" lIns="0" tIns="0" rIns="0" bIns="0" rtlCol="0" anchor="t"/>
+          <a:lstStyle/>
+          <a:p>
+            <a:pPr indent="0" marL="0">
+              <a:buNone/>
+            </a:pPr>
+            <a:r>
+              <a:rPr lang="en-US" sz="1300" dirty="0">
+                <a:solidFill>
+                  <a:srgbClr val="26262F"/>
+                </a:solidFill>
+                <a:latin typeface="Calibri" pitchFamily="34" charset="0"/>
+                <a:ea typeface="Calibri" pitchFamily="34" charset="-122"/>
+                <a:cs typeface="Calibri" pitchFamily="34" charset="-120"/>
+              </a:rPr>
+              <a:t>Coercion happens strictly left to right, one operation at a time — the ORDER of mixed operands changes the result. These are exactly the surprises === avoids.</a:t>
+            </a:r>
+            <a:endParaRPr lang="en-US" sz="1300" dirty="0"/>
+          </a:p>
+        </p:txBody>
+      </p:sp>
+      <p:sp>
+        <p:nvSpPr>
+          <p:cNvPr id="9" name="cuinotes-footer-mark"/>
+          <p:cNvSpPr txBox="1"/>
+          <p:nvPr/>
+        </p:nvSpPr>
+        <p:spPr>
+          <a:xfrm>
+            <a:off x="9951720" y="6455664"/>
+            <a:ext cx="2011680" cy="292608"/>
+          </a:xfrm>
+          <a:prstGeom prst="rect">
+            <a:avLst/>
+          </a:prstGeom>
+          <a:noFill/>
+        </p:spPr>
+        <p:txBody>
+          <a:bodyPr wrap="none" lIns="0" rIns="0" tIns="0" bIns="0">
+            <a:spAutoFit/>
+          </a:bodyPr>
+          <a:lstStyle/>
+          <a:p>
+            <a:pPr algn="r"/>
+            <a:r>
+              <a:rPr sz="1000">
+                <a:solidFill>
+                  <a:srgbClr val="8A939B"/>
+                </a:solidFill>
+                <a:hlinkClick r:id="rId3"/>
+              </a:rPr>
+              <a:t>cuinotes.com</a:t>
+            </a:r>
+            <a:r>
+              <a:rPr sz="1000">
+                <a:solidFill>
+                  <a:srgbClr val="8A939B"/>
+                </a:solidFill>
+              </a:rPr>
+              <a:t>  ·  15</a:t>
+            </a:r>
+          </a:p>
+        </p:txBody>
+      </p:sp>
+    </p:spTree>
+  </p:cSld>
+  <p:clrMapOvr>
+    <a:masterClrMapping/>
+  </p:clrMapOvr>
+</p:sld>
+</file>
+
+<file path=ppt/slides/slide41.xml><?xml version="1.0" encoding="utf-8"?>
+<p:sld xmlns:a="http://schemas.openxmlformats.org/drawingml/2006/main" xmlns:r="http://schemas.openxmlformats.org/officeDocument/2006/relationships" xmlns:p="http://schemas.openxmlformats.org/presentationml/2006/main">
+  <p:cSld name="Slide 16">
+    <p:bg>
+      <p:bgPr>
+        <a:solidFill>
+          <a:srgbClr val="FFFFFF"/>
+        </a:solidFill>
+      </p:bgPr>
+    </p:bg>
+    <p:spTree>
+      <p:nvGrpSpPr>
+        <p:cNvPr id="1" name=""/>
+        <p:cNvGrpSpPr/>
+        <p:nvPr/>
+      </p:nvGrpSpPr>
+      <p:grpSpPr>
+        <a:xfrm>
+          <a:off x="0" y="0"/>
+          <a:ext cx="0" cy="0"/>
+          <a:chOff x="0" y="0"/>
+          <a:chExt cx="0" cy="0"/>
+        </a:xfrm>
+      </p:grpSpPr>
+      <p:sp>
+        <p:nvSpPr>
+          <p:cNvPr id="2" name="Text 0"/>
+          <p:cNvSpPr txBox="1"/>
+          <p:nvPr/>
+        </p:nvSpPr>
+        <p:spPr>
+          <a:xfrm>
+            <a:off x="640080" y="457200"/>
+            <a:ext cx="10058400" cy="365760"/>
+          </a:xfrm>
+          <a:prstGeom prst="rect">
+            <a:avLst/>
+          </a:prstGeom>
+          <a:noFill/>
+          <a:ln/>
+        </p:spPr>
+        <p:txBody>
+          <a:bodyPr wrap="square" lIns="0" tIns="0" rIns="0" bIns="0" rtlCol="0" anchor="ctr"/>
+          <a:lstStyle/>
+          <a:p>
+            <a:pPr algn="l" indent="0" marL="0">
+              <a:buNone/>
+            </a:pPr>
+            <a:r>
+              <a:rPr lang="en-US" sz="1300" b="1" spc="300" kern="0" dirty="0">
+                <a:solidFill>
+                  <a:srgbClr val="FF8A3D"/>
+                </a:solidFill>
+                <a:latin typeface="Calibri" pitchFamily="34" charset="0"/>
+                <a:ea typeface="Calibri" pitchFamily="34" charset="-122"/>
+                <a:cs typeface="Calibri" pitchFamily="34" charset="-120"/>
+              </a:rPr>
+              <a:t>OPERATORS</a:t>
+            </a:r>
+            <a:endParaRPr lang="en-US" sz="1300" dirty="0"/>
+          </a:p>
+        </p:txBody>
+      </p:sp>
+      <p:sp>
+        <p:nvSpPr>
+          <p:cNvPr id="3" name="Text 1"/>
+          <p:cNvSpPr txBox="1"/>
+          <p:nvPr/>
+        </p:nvSpPr>
+        <p:spPr>
+          <a:xfrm>
+            <a:off x="640080" y="841248"/>
+            <a:ext cx="10881360" cy="914400"/>
+          </a:xfrm>
+          <a:prstGeom prst="rect">
+            <a:avLst/>
+          </a:prstGeom>
+          <a:noFill/>
+          <a:ln/>
+        </p:spPr>
+        <p:txBody>
+          <a:bodyPr wrap="square" lIns="0" tIns="0" rIns="0" bIns="0" rtlCol="0" anchor="ctr"/>
+          <a:lstStyle/>
+          <a:p>
+            <a:pPr algn="l" indent="0" marL="0">
+              <a:buNone/>
+            </a:pPr>
+            <a:r>
+              <a:rPr lang="en-US" sz="3400" b="1" dirty="0">
+                <a:solidFill>
+                  <a:srgbClr val="2B2B7A"/>
+                </a:solidFill>
+                <a:latin typeface="Cambria" pitchFamily="34" charset="0"/>
+                <a:ea typeface="Cambria" pitchFamily="34" charset="-122"/>
+                <a:cs typeface="Cambria" pitchFamily="34" charset="-120"/>
+              </a:rPr>
+              <a:t>Explicit Type Conversion</a:t>
+            </a:r>
+            <a:endParaRPr lang="en-US" sz="3400" dirty="0"/>
+          </a:p>
+        </p:txBody>
+      </p:sp>
+      <p:sp>
+        <p:nvSpPr>
+          <p:cNvPr id="4" name="Shape 2"/>
+          <p:cNvSpPr/>
+          <p:nvPr/>
+        </p:nvSpPr>
+        <p:spPr>
+          <a:xfrm>
+            <a:off x="640080" y="1965960"/>
+            <a:ext cx="10911535" cy="2452116"/>
+          </a:xfrm>
+          <a:prstGeom prst="roundRect">
+            <a:avLst>
+              <a:gd name="adj" fmla="val 3887"/>
+            </a:avLst>
+          </a:prstGeom>
+          <a:solidFill>
+            <a:srgbClr val="1E1E4C"/>
+          </a:solidFill>
+          <a:ln/>
+        </p:spPr>
+        <p:txBody>
+          <a:bodyPr/>
+          <a:p/>
+        </p:txBody>
+      </p:sp>
+      <p:sp>
+        <p:nvSpPr>
+          <p:cNvPr id="5" name="Text 3"/>
+          <p:cNvSpPr txBox="1"/>
+          <p:nvPr/>
+        </p:nvSpPr>
+        <p:spPr>
+          <a:xfrm>
+            <a:off x="960120" y="2194560"/>
+            <a:ext cx="10271455" cy="1994916"/>
+          </a:xfrm>
+          <a:prstGeom prst="rect">
+            <a:avLst/>
+          </a:prstGeom>
+          <a:noFill/>
+          <a:ln/>
+        </p:spPr>
+        <p:txBody>
+          <a:bodyPr wrap="square" lIns="0" tIns="0" rIns="0" bIns="0" rtlCol="0" anchor="t"/>
+          <a:lstStyle/>
+          <a:p>
+            <a:pPr indent="0" marL="0">
+              <a:lnSpc>
+                <a:spcPct val="125000"/>
+              </a:lnSpc>
+              <a:buNone/>
+            </a:pPr>
+            <a:r>
+              <a:rPr lang="en-US" sz="1400" dirty="0">
+                <a:solidFill>
+                  <a:srgbClr val="C9D3F5"/>
+                </a:solidFill>
+                <a:latin typeface="Courier New" pitchFamily="34" charset="0"/>
+                <a:ea typeface="Courier New" pitchFamily="34" charset="-122"/>
+                <a:cs typeface="Courier New" pitchFamily="34" charset="-120"/>
+              </a:rPr>
+              <a:t>console.log(Number("42"));      // 42     -- string to number</a:t>
+            </a:r>
+            <a:endParaRPr lang="en-US" sz="1400" dirty="0"/>
+          </a:p>
+          <a:p>
+            <a:pPr indent="0" marL="0">
+              <a:lnSpc>
+                <a:spcPct val="125000"/>
+              </a:lnSpc>
+              <a:buNone/>
+            </a:pPr>
+            <a:r>
+              <a:rPr lang="en-US" sz="1400" dirty="0">
+                <a:solidFill>
+                  <a:srgbClr val="C9D3F5"/>
+                </a:solidFill>
+                <a:latin typeface="Courier New" pitchFamily="34" charset="0"/>
+                <a:ea typeface="Courier New" pitchFamily="34" charset="-122"/>
+                <a:cs typeface="Courier New" pitchFamily="34" charset="-120"/>
+              </a:rPr>
+              <a:t>console.log(Number(""));        // 0      -- empty string converts to 0</a:t>
+            </a:r>
+            <a:endParaRPr lang="en-US" sz="1400" dirty="0"/>
+          </a:p>
+          <a:p>
+            <a:pPr indent="0" marL="0">
+              <a:lnSpc>
+                <a:spcPct val="125000"/>
+              </a:lnSpc>
+              <a:buNone/>
+            </a:pPr>
+            <a:r>
+              <a:rPr lang="en-US" sz="1400" dirty="0">
+                <a:solidFill>
+                  <a:srgbClr val="C9D3F5"/>
+                </a:solidFill>
+                <a:latin typeface="Courier New" pitchFamily="34" charset="0"/>
+                <a:ea typeface="Courier New" pitchFamily="34" charset="-122"/>
+                <a:cs typeface="Courier New" pitchFamily="34" charset="-120"/>
+              </a:rPr>
+              <a:t>console.log(Number("abc"));     // NaN    -- not a valid number</a:t>
+            </a:r>
+            <a:endParaRPr lang="en-US" sz="1400" dirty="0"/>
+          </a:p>
+          <a:p>
+            <a:pPr indent="0" marL="0">
+              <a:lnSpc>
+                <a:spcPct val="125000"/>
+              </a:lnSpc>
+              <a:buNone/>
+            </a:pPr>
+            <a:r>
+              <a:rPr lang="en-US" sz="1400" dirty="0">
+                <a:solidFill>
+                  <a:srgbClr val="C9D3F5"/>
+                </a:solidFill>
+                <a:latin typeface="Courier New" pitchFamily="34" charset="0"/>
+                <a:ea typeface="Courier New" pitchFamily="34" charset="-122"/>
+                <a:cs typeface="Courier New" pitchFamily="34" charset="-120"/>
+              </a:rPr>
+              <a:t>console.log(String(42));        // "42"   -- number to string</a:t>
+            </a:r>
+            <a:endParaRPr lang="en-US" sz="1400" dirty="0"/>
+          </a:p>
+          <a:p>
+            <a:pPr indent="0" marL="0">
+              <a:lnSpc>
+                <a:spcPct val="125000"/>
+              </a:lnSpc>
+              <a:buNone/>
+            </a:pPr>
+            <a:r>
+              <a:rPr lang="en-US" sz="1400" dirty="0">
+                <a:solidFill>
+                  <a:srgbClr val="C9D3F5"/>
+                </a:solidFill>
+                <a:latin typeface="Courier New" pitchFamily="34" charset="0"/>
+                <a:ea typeface="Courier New" pitchFamily="34" charset="-122"/>
+                <a:cs typeface="Courier New" pitchFamily="34" charset="-120"/>
+              </a:rPr>
+              <a:t>console.log(Boolean(0));        // false  -- falsy: 0, "", null, undefined, NaN</a:t>
+            </a:r>
+            <a:endParaRPr lang="en-US" sz="1400" dirty="0"/>
+          </a:p>
+          <a:p>
+            <a:pPr indent="0" marL="0">
+              <a:lnSpc>
+                <a:spcPct val="125000"/>
+              </a:lnSpc>
+              <a:buNone/>
+            </a:pPr>
+            <a:r>
+              <a:rPr lang="en-US" sz="1400" dirty="0">
+                <a:solidFill>
+                  <a:srgbClr val="C9D3F5"/>
+                </a:solidFill>
+                <a:latin typeface="Courier New" pitchFamily="34" charset="0"/>
+                <a:ea typeface="Courier New" pitchFamily="34" charset="-122"/>
+                <a:cs typeface="Courier New" pitchFamily="34" charset="-120"/>
+              </a:rPr>
+              <a:t>console.log(Boolean("hi"));     // true   -- any non-empty string is truthy</a:t>
+            </a:r>
+            <a:endParaRPr lang="en-US" sz="1400" dirty="0"/>
+          </a:p>
+          <a:p>
+            <a:pPr indent="0" marL="0">
+              <a:lnSpc>
+                <a:spcPct val="125000"/>
+              </a:lnSpc>
+              <a:buNone/>
+            </a:pPr>
+            <a:r>
+              <a:rPr lang="en-US" sz="1400" dirty="0">
+                <a:solidFill>
+                  <a:srgbClr val="C9D3F5"/>
+                </a:solidFill>
+                <a:latin typeface="Courier New" pitchFamily="34" charset="0"/>
+                <a:ea typeface="Courier New" pitchFamily="34" charset="-122"/>
+                <a:cs typeface="Courier New" pitchFamily="34" charset="-120"/>
+              </a:rPr>
+              <a:t>console.log(parseInt("42px"));  // 42     -- parses leading digits, ignores the rest</a:t>
+            </a:r>
+            <a:endParaRPr lang="en-US" sz="1400" dirty="0"/>
+          </a:p>
+        </p:txBody>
+      </p:sp>
+      <p:sp>
+        <p:nvSpPr>
+          <p:cNvPr id="6" name="Text 4"/>
+          <p:cNvSpPr txBox="1"/>
+          <p:nvPr/>
+        </p:nvSpPr>
+        <p:spPr>
+          <a:xfrm>
+            <a:off x="640080" y="4646676"/>
+            <a:ext cx="10911535" cy="1658988"/>
+          </a:xfrm>
+          <a:prstGeom prst="rect">
+            <a:avLst/>
+          </a:prstGeom>
+          <a:noFill/>
+          <a:ln/>
+        </p:spPr>
+        <p:txBody>
+          <a:bodyPr wrap="square" lIns="0" tIns="0" rIns="0" bIns="0" rtlCol="0" anchor="t"/>
+          <a:lstStyle/>
+          <a:p>
+            <a:pPr indent="0" marL="0">
+              <a:buNone/>
+            </a:pPr>
+            <a:r>
+              <a:rPr lang="en-US" sz="1300" dirty="0">
+                <a:solidFill>
+                  <a:srgbClr val="26262F"/>
+                </a:solidFill>
+                <a:latin typeface="Calibri" pitchFamily="34" charset="0"/>
+                <a:ea typeface="Calibri" pitchFamily="34" charset="-122"/>
+                <a:cs typeface="Calibri" pitchFamily="34" charset="-120"/>
+              </a:rPr>
+              <a:t>Number(), String(), and Boolean() explicitly convert a value’s type — unlike coercion, the conversion is intentional and visible in the code. parseInt()/parseFloat() pull a leading number out of a string.</a:t>
+            </a:r>
+            <a:endParaRPr lang="en-US" sz="1300" dirty="0"/>
+          </a:p>
+        </p:txBody>
+      </p:sp>
+      <p:sp>
+        <p:nvSpPr>
+          <p:cNvPr id="9" name="cuinotes-footer-mark"/>
+          <p:cNvSpPr txBox="1"/>
+          <p:nvPr/>
+        </p:nvSpPr>
+        <p:spPr>
+          <a:xfrm>
+            <a:off x="9951720" y="6455664"/>
+            <a:ext cx="2011680" cy="292608"/>
+          </a:xfrm>
+          <a:prstGeom prst="rect">
+            <a:avLst/>
+          </a:prstGeom>
+          <a:noFill/>
+        </p:spPr>
+        <p:txBody>
+          <a:bodyPr wrap="none" lIns="0" rIns="0" tIns="0" bIns="0">
+            <a:spAutoFit/>
+          </a:bodyPr>
+          <a:lstStyle/>
+          <a:p>
+            <a:pPr algn="r"/>
+            <a:r>
+              <a:rPr sz="1000">
+                <a:solidFill>
+                  <a:srgbClr val="8A939B"/>
+                </a:solidFill>
+                <a:hlinkClick r:id="rId3"/>
+              </a:rPr>
+              <a:t>cuinotes.com</a:t>
+            </a:r>
+            <a:r>
+              <a:rPr sz="1000">
+                <a:solidFill>
+                  <a:srgbClr val="8A939B"/>
+                </a:solidFill>
+              </a:rPr>
+              <a:t>  ·  16</a:t>
             </a:r>
           </a:p>
         </p:txBody>

</xml_diff>